<commit_message>
Update PPTX with exact problem statement text
</commit_message>
<xml_diff>
--- a/Problem_Statement_29.pptx
+++ b/Problem_Statement_29.pptx
@@ -8,9 +8,6 @@
     <p:sldId id="256" r:id="rId7"/>
     <p:sldId id="257" r:id="rId8"/>
     <p:sldId id="258" r:id="rId9"/>
-    <p:sldId id="259" r:id="rId10"/>
-    <p:sldId id="260" r:id="rId11"/>
-    <p:sldId id="261" r:id="rId12"/>
   </p:sldIdLst>
   <p:sldSz cx="12191695" cy="6858000" type="screen4x3"/>
   <p:notesSz cx="6858000" cy="9144000"/>
@@ -3130,7 +3127,7 @@
                   <a:srgbClr val="FF6B00"/>
                 </a:solidFill>
               </a:rPr>
-              <a:t>Problem Statement No. 29</a:t>
+              <a:t>Problem Statement No.29</a:t>
             </a:r>
           </a:p>
         </p:txBody>
@@ -3165,40 +3162,6 @@
                 </a:solidFill>
               </a:rPr>
               <a:t>Street Vendor Digitalization Agent</a:t>
-            </a:r>
-          </a:p>
-        </p:txBody>
-      </p:sp>
-      <p:sp>
-        <p:nvSpPr>
-          <p:cNvPr id="4" name="TextBox 3"/>
-          <p:cNvSpPr txBox="1"/>
-          <p:nvPr/>
-        </p:nvSpPr>
-        <p:spPr>
-          <a:xfrm>
-            <a:off x="914400" y="5029200"/>
-            <a:ext cx="10058400" cy="914400"/>
-          </a:xfrm>
-          <a:prstGeom prst="rect">
-            <a:avLst/>
-          </a:prstGeom>
-          <a:noFill/>
-        </p:spPr>
-        <p:txBody>
-          <a:bodyPr wrap="none">
-            <a:spAutoFit/>
-          </a:bodyPr>
-          <a:lstStyle/>
-          <a:p>
-            <a:pPr algn="ctr"/>
-            <a:r>
-              <a:rPr sz="2400">
-                <a:solidFill>
-                  <a:srgbClr val="1A7A4A"/>
-                </a:solidFill>
-              </a:rPr>
-              <a:t>AICTE-IBM SkillsBuild Internship 2026</a:t>
             </a:r>
           </a:p>
         </p:txBody>
@@ -3237,8 +3200,8 @@
         </p:nvSpPr>
         <p:spPr>
           <a:xfrm>
-            <a:off x="731520" y="457200"/>
-            <a:ext cx="10058400" cy="914400"/>
+            <a:off x="731520" y="365760"/>
+            <a:ext cx="10515600" cy="5943600"/>
           </a:xfrm>
           <a:prstGeom prst="rect">
             <a:avLst/>
@@ -3246,116 +3209,23 @@
           <a:noFill/>
         </p:spPr>
         <p:txBody>
-          <a:bodyPr wrap="none">
-            <a:spAutoFit/>
-          </a:bodyPr>
-          <a:lstStyle/>
-          <a:p>
-            <a:r>
-              <a:rPr sz="4400" b="1">
-                <a:solidFill>
-                  <a:srgbClr val="FF6B00"/>
-                </a:solidFill>
-              </a:rPr>
-              <a:t>The Challenge</a:t>
-            </a:r>
-          </a:p>
-        </p:txBody>
-      </p:sp>
-      <p:sp>
-        <p:nvSpPr>
-          <p:cNvPr id="3" name="TextBox 2"/>
-          <p:cNvSpPr txBox="1"/>
-          <p:nvPr/>
-        </p:nvSpPr>
-        <p:spPr>
-          <a:xfrm>
-            <a:off x="731520" y="1645920"/>
-            <a:ext cx="10515600" cy="4572000"/>
-          </a:xfrm>
-          <a:prstGeom prst="rect">
-            <a:avLst/>
-          </a:prstGeom>
-          <a:noFill/>
-        </p:spPr>
-        <p:txBody>
           <a:bodyPr wrap="square">
             <a:spAutoFit/>
           </a:bodyPr>
           <a:lstStyle/>
           <a:p>
-            <a:pPr>
-              <a:spcAft>
-                <a:spcPts val="1600"/>
-              </a:spcAft>
-            </a:pPr>
             <a:r>
               <a:rPr sz="2200">
                 <a:solidFill>
-                  <a:srgbClr val="333333"/>
+                  <a:srgbClr val="222222"/>
                 </a:solidFill>
               </a:rPr>
-              <a:t>A Street Vendor Digitalization Agent, powered by RAG (Retrieval-Augmented Generation), helps local hawkers and micro-entrepreneurs become digitally visible by generating:</a:t>
-            </a:r>
-          </a:p>
-          <a:p>
-            <a:pPr>
-              <a:spcBef>
-                <a:spcPts val="800"/>
-              </a:spcBef>
-            </a:pPr>
-            <a:r>
-              <a:rPr sz="2000">
-                <a:solidFill>
-                  <a:srgbClr val="333333"/>
-                </a:solidFill>
-              </a:rPr>
-              <a:t>  •  Business profiles</a:t>
-            </a:r>
-          </a:p>
-          <a:p>
-            <a:pPr>
-              <a:spcBef>
-                <a:spcPts val="800"/>
-              </a:spcBef>
-            </a:pPr>
-            <a:r>
-              <a:rPr sz="2000">
-                <a:solidFill>
-                  <a:srgbClr val="333333"/>
-                </a:solidFill>
-              </a:rPr>
-              <a:t>  •  UPI setup guides</a:t>
-            </a:r>
-          </a:p>
-          <a:p>
-            <a:pPr>
-              <a:spcBef>
-                <a:spcPts val="800"/>
-              </a:spcBef>
-            </a:pPr>
-            <a:r>
-              <a:rPr sz="2000">
-                <a:solidFill>
-                  <a:srgbClr val="333333"/>
-                </a:solidFill>
-              </a:rPr>
-              <a:t>  •  Local SEO strategies</a:t>
-            </a:r>
-          </a:p>
-          <a:p>
-            <a:pPr>
-              <a:spcBef>
-                <a:spcPts val="800"/>
-              </a:spcBef>
-            </a:pPr>
-            <a:r>
-              <a:rPr sz="2000">
-                <a:solidFill>
-                  <a:srgbClr val="333333"/>
-                </a:solidFill>
-              </a:rPr>
-              <a:t>  •  Customer engagement tips</a:t>
+              <a:t>Problem Statement No.29 – Street Vendor Digitalization Agent
+The Challenge – A Street Vendor Digitalization Agent, powered by RAG (Retrieval-Augmented Generation), helps local hawkers and micro-entrepreneurs become digitally visible by generating business profiles, UPI setup guides, local SEO strategies, and customer engagement tips.
+It retrieves real-time policies, MSME schemes, geolocation of business data, digital onboarding steps, and consumer behavior insights from government portals, fintech apps, and commerce platforms.
+Vendors can simply say, "I sell fruit in Pune's Camp area," and the agent will suggest pricing tips, online listing platforms, QR code setup, and promotional materials in their local language.
+This AI-driven assistant empowers informal businesses to grow digitally, unlock access to credit, and boost visibility in the hyperlocal economy.
+Technology – Use of IBM Cloud Lite services / IBM Granite is mandatory.</a:t>
             </a:r>
           </a:p>
         </p:txBody>
@@ -3369,238 +3239,6 @@
 </file>
 
 <file path=ppt/slides/slide3.xml><?xml version="1.0" encoding="utf-8"?>
-<p:sld xmlns:a="http://schemas.openxmlformats.org/drawingml/2006/main" xmlns:p="http://schemas.openxmlformats.org/presentationml/2006/main" xmlns:r="http://schemas.openxmlformats.org/officeDocument/2006/relationships">
-  <p:cSld>
-    <p:bg>
-      <p:bgPr>
-        <a:solidFill>
-          <a:srgbClr val="FFFFFF"/>
-        </a:solidFill>
-        <a:effectLst/>
-      </p:bgPr>
-    </p:bg>
-    <p:spTree>
-      <p:nvGrpSpPr>
-        <p:cNvPr id="1" name=""/>
-        <p:cNvGrpSpPr/>
-        <p:nvPr/>
-      </p:nvGrpSpPr>
-      <p:grpSpPr/>
-      <p:sp>
-        <p:nvSpPr>
-          <p:cNvPr id="2" name="TextBox 1"/>
-          <p:cNvSpPr txBox="1"/>
-          <p:nvPr/>
-        </p:nvSpPr>
-        <p:spPr>
-          <a:xfrm>
-            <a:off x="731520" y="457200"/>
-            <a:ext cx="10058400" cy="914400"/>
-          </a:xfrm>
-          <a:prstGeom prst="rect">
-            <a:avLst/>
-          </a:prstGeom>
-          <a:noFill/>
-        </p:spPr>
-        <p:txBody>
-          <a:bodyPr wrap="none">
-            <a:spAutoFit/>
-          </a:bodyPr>
-          <a:lstStyle/>
-          <a:p>
-            <a:r>
-              <a:rPr sz="4400" b="1">
-                <a:solidFill>
-                  <a:srgbClr val="1A7A4A"/>
-                </a:solidFill>
-              </a:rPr>
-              <a:t>What It Does</a:t>
-            </a:r>
-          </a:p>
-        </p:txBody>
-      </p:sp>
-      <p:sp>
-        <p:nvSpPr>
-          <p:cNvPr id="3" name="TextBox 2"/>
-          <p:cNvSpPr txBox="1"/>
-          <p:nvPr/>
-        </p:nvSpPr>
-        <p:spPr>
-          <a:xfrm>
-            <a:off x="731520" y="1645920"/>
-            <a:ext cx="10515600" cy="4572000"/>
-          </a:xfrm>
-          <a:prstGeom prst="rect">
-            <a:avLst/>
-          </a:prstGeom>
-          <a:noFill/>
-        </p:spPr>
-        <p:txBody>
-          <a:bodyPr wrap="square">
-            <a:spAutoFit/>
-          </a:bodyPr>
-          <a:lstStyle/>
-          <a:p>
-            <a:pPr>
-              <a:spcBef>
-                <a:spcPts val="600"/>
-              </a:spcBef>
-            </a:pPr>
-            <a:r>
-              <a:rPr sz="2000" b="1">
-                <a:solidFill>
-                  <a:srgbClr val="333333"/>
-                </a:solidFill>
-              </a:rPr>
-              <a:t>Real-time data retrieval from:</a:t>
-            </a:r>
-          </a:p>
-          <a:p>
-            <a:pPr>
-              <a:spcBef>
-                <a:spcPts val="600"/>
-              </a:spcBef>
-            </a:pPr>
-            <a:r>
-              <a:rPr sz="2000" b="0">
-                <a:solidFill>
-                  <a:srgbClr val="333333"/>
-                </a:solidFill>
-              </a:rPr>
-              <a:t>  •  Government portals</a:t>
-            </a:r>
-          </a:p>
-          <a:p>
-            <a:pPr>
-              <a:spcBef>
-                <a:spcPts val="600"/>
-              </a:spcBef>
-            </a:pPr>
-            <a:r>
-              <a:rPr sz="2000" b="0">
-                <a:solidFill>
-                  <a:srgbClr val="333333"/>
-                </a:solidFill>
-              </a:rPr>
-              <a:t>  •  Fintech apps</a:t>
-            </a:r>
-          </a:p>
-          <a:p>
-            <a:pPr>
-              <a:spcBef>
-                <a:spcPts val="600"/>
-              </a:spcBef>
-            </a:pPr>
-            <a:r>
-              <a:rPr sz="2000" b="0">
-                <a:solidFill>
-                  <a:srgbClr val="333333"/>
-                </a:solidFill>
-              </a:rPr>
-              <a:t>  •  Commerce platforms</a:t>
-            </a:r>
-          </a:p>
-          <a:p>
-            <a:pPr>
-              <a:spcBef>
-                <a:spcPts val="600"/>
-              </a:spcBef>
-            </a:pPr>
-            <a:r>
-              <a:rPr sz="2000" b="0">
-                <a:solidFill>
-                  <a:srgbClr val="333333"/>
-                </a:solidFill>
-              </a:rPr>
-              <a:t/>
-            </a:r>
-          </a:p>
-          <a:p>
-            <a:pPr>
-              <a:spcBef>
-                <a:spcPts val="600"/>
-              </a:spcBef>
-            </a:pPr>
-            <a:r>
-              <a:rPr sz="2000" b="1">
-                <a:solidFill>
-                  <a:srgbClr val="333333"/>
-                </a:solidFill>
-              </a:rPr>
-              <a:t>Retrieves:</a:t>
-            </a:r>
-          </a:p>
-          <a:p>
-            <a:pPr>
-              <a:spcBef>
-                <a:spcPts val="600"/>
-              </a:spcBef>
-            </a:pPr>
-            <a:r>
-              <a:rPr sz="2000" b="0">
-                <a:solidFill>
-                  <a:srgbClr val="333333"/>
-                </a:solidFill>
-              </a:rPr>
-              <a:t>  •  Real-time policies &amp; MSME schemes</a:t>
-            </a:r>
-          </a:p>
-          <a:p>
-            <a:pPr>
-              <a:spcBef>
-                <a:spcPts val="600"/>
-              </a:spcBef>
-            </a:pPr>
-            <a:r>
-              <a:rPr sz="2000" b="0">
-                <a:solidFill>
-                  <a:srgbClr val="333333"/>
-                </a:solidFill>
-              </a:rPr>
-              <a:t>  •  Geolocation of business data</a:t>
-            </a:r>
-          </a:p>
-          <a:p>
-            <a:pPr>
-              <a:spcBef>
-                <a:spcPts val="600"/>
-              </a:spcBef>
-            </a:pPr>
-            <a:r>
-              <a:rPr sz="2000" b="0">
-                <a:solidFill>
-                  <a:srgbClr val="333333"/>
-                </a:solidFill>
-              </a:rPr>
-              <a:t>  •  Digital onboarding steps</a:t>
-            </a:r>
-          </a:p>
-          <a:p>
-            <a:pPr>
-              <a:spcBef>
-                <a:spcPts val="600"/>
-              </a:spcBef>
-            </a:pPr>
-            <a:r>
-              <a:rPr sz="2000" b="0">
-                <a:solidFill>
-                  <a:srgbClr val="333333"/>
-                </a:solidFill>
-              </a:rPr>
-              <a:t>  •  Consumer behavior insights</a:t>
-            </a:r>
-          </a:p>
-        </p:txBody>
-      </p:sp>
-    </p:spTree>
-  </p:cSld>
-  <p:clrMapOvr>
-    <a:masterClrMapping/>
-  </p:clrMapOvr>
-</p:sld>
-</file>
-
-<file path=ppt/slides/slide4.xml><?xml version="1.0" encoding="utf-8"?>
 <p:sld xmlns:a="http://schemas.openxmlformats.org/drawingml/2006/main" xmlns:p="http://schemas.openxmlformats.org/presentationml/2006/main" xmlns:r="http://schemas.openxmlformats.org/officeDocument/2006/relationships">
   <p:cSld>
     <p:bg>
@@ -3626,437 +3264,6 @@
         </p:nvSpPr>
         <p:spPr>
           <a:xfrm>
-            <a:off x="731520" y="457200"/>
-            <a:ext cx="10058400" cy="914400"/>
-          </a:xfrm>
-          <a:prstGeom prst="rect">
-            <a:avLst/>
-          </a:prstGeom>
-          <a:noFill/>
-        </p:spPr>
-        <p:txBody>
-          <a:bodyPr wrap="none">
-            <a:spAutoFit/>
-          </a:bodyPr>
-          <a:lstStyle/>
-          <a:p>
-            <a:r>
-              <a:rPr sz="4400" b="1">
-                <a:solidFill>
-                  <a:srgbClr val="FF6B00"/>
-                </a:solidFill>
-              </a:rPr>
-              <a:t>Example Usage</a:t>
-            </a:r>
-          </a:p>
-        </p:txBody>
-      </p:sp>
-      <p:sp>
-        <p:nvSpPr>
-          <p:cNvPr id="3" name="TextBox 2"/>
-          <p:cNvSpPr txBox="1"/>
-          <p:nvPr/>
-        </p:nvSpPr>
-        <p:spPr>
-          <a:xfrm>
-            <a:off x="731520" y="1828800"/>
-            <a:ext cx="10515600" cy="1371600"/>
-          </a:xfrm>
-          <a:prstGeom prst="rect">
-            <a:avLst/>
-          </a:prstGeom>
-          <a:noFill/>
-        </p:spPr>
-        <p:txBody>
-          <a:bodyPr wrap="square">
-            <a:spAutoFit/>
-          </a:bodyPr>
-          <a:lstStyle/>
-          <a:p>
-            <a:pPr algn="ctr"/>
-            <a:r>
-              <a:rPr sz="3000" i="1">
-                <a:solidFill>
-                  <a:srgbClr val="FFFFFF"/>
-                </a:solidFill>
-              </a:rPr>
-              <a:t>"I sell fruit in Pune's Camp area."</a:t>
-            </a:r>
-          </a:p>
-        </p:txBody>
-      </p:sp>
-      <p:sp>
-        <p:nvSpPr>
-          <p:cNvPr id="4" name="TextBox 3"/>
-          <p:cNvSpPr txBox="1"/>
-          <p:nvPr/>
-        </p:nvSpPr>
-        <p:spPr>
-          <a:xfrm>
-            <a:off x="1371600" y="3657600"/>
-            <a:ext cx="9144000" cy="2743200"/>
-          </a:xfrm>
-          <a:prstGeom prst="rect">
-            <a:avLst/>
-          </a:prstGeom>
-          <a:noFill/>
-        </p:spPr>
-        <p:txBody>
-          <a:bodyPr wrap="square">
-            <a:spAutoFit/>
-          </a:bodyPr>
-          <a:lstStyle/>
-          <a:p>
-            <a:r>
-              <a:rPr sz="2200" b="1">
-                <a:solidFill>
-                  <a:srgbClr val="1A7A4A"/>
-                </a:solidFill>
-              </a:rPr>
-              <a:t>The agent suggests:</a:t>
-            </a:r>
-          </a:p>
-          <a:p>
-            <a:pPr>
-              <a:spcBef>
-                <a:spcPts val="1000"/>
-              </a:spcBef>
-            </a:pPr>
-            <a:r>
-              <a:rPr sz="2000">
-                <a:solidFill>
-                  <a:srgbClr val="FFFFFF"/>
-                </a:solidFill>
-              </a:rPr>
-              <a:t>  ✅  Pricing tips for local market</a:t>
-            </a:r>
-          </a:p>
-          <a:p>
-            <a:pPr>
-              <a:spcBef>
-                <a:spcPts val="1000"/>
-              </a:spcBef>
-            </a:pPr>
-            <a:r>
-              <a:rPr sz="2000">
-                <a:solidFill>
-                  <a:srgbClr val="FFFFFF"/>
-                </a:solidFill>
-              </a:rPr>
-              <a:t>  ✅  Online listing platforms (Google, Swiggy, Zomato)</a:t>
-            </a:r>
-          </a:p>
-          <a:p>
-            <a:pPr>
-              <a:spcBef>
-                <a:spcPts val="1000"/>
-              </a:spcBef>
-            </a:pPr>
-            <a:r>
-              <a:rPr sz="2000">
-                <a:solidFill>
-                  <a:srgbClr val="FFFFFF"/>
-                </a:solidFill>
-              </a:rPr>
-              <a:t>  ✅  QR code setup for UPI payments</a:t>
-            </a:r>
-          </a:p>
-          <a:p>
-            <a:pPr>
-              <a:spcBef>
-                <a:spcPts val="1000"/>
-              </a:spcBef>
-            </a:pPr>
-            <a:r>
-              <a:rPr sz="2000">
-                <a:solidFill>
-                  <a:srgbClr val="FFFFFF"/>
-                </a:solidFill>
-              </a:rPr>
-              <a:t>  ✅  Promotional materials in local language</a:t>
-            </a:r>
-          </a:p>
-        </p:txBody>
-      </p:sp>
-    </p:spTree>
-  </p:cSld>
-  <p:clrMapOvr>
-    <a:masterClrMapping/>
-  </p:clrMapOvr>
-</p:sld>
-</file>
-
-<file path=ppt/slides/slide5.xml><?xml version="1.0" encoding="utf-8"?>
-<p:sld xmlns:a="http://schemas.openxmlformats.org/drawingml/2006/main" xmlns:p="http://schemas.openxmlformats.org/presentationml/2006/main" xmlns:r="http://schemas.openxmlformats.org/officeDocument/2006/relationships">
-  <p:cSld>
-    <p:bg>
-      <p:bgPr>
-        <a:solidFill>
-          <a:srgbClr val="FFFFFF"/>
-        </a:solidFill>
-        <a:effectLst/>
-      </p:bgPr>
-    </p:bg>
-    <p:spTree>
-      <p:nvGrpSpPr>
-        <p:cNvPr id="1" name=""/>
-        <p:cNvGrpSpPr/>
-        <p:nvPr/>
-      </p:nvGrpSpPr>
-      <p:grpSpPr/>
-      <p:sp>
-        <p:nvSpPr>
-          <p:cNvPr id="2" name="TextBox 1"/>
-          <p:cNvSpPr txBox="1"/>
-          <p:nvPr/>
-        </p:nvSpPr>
-        <p:spPr>
-          <a:xfrm>
-            <a:off x="731520" y="457200"/>
-            <a:ext cx="10058400" cy="914400"/>
-          </a:xfrm>
-          <a:prstGeom prst="rect">
-            <a:avLst/>
-          </a:prstGeom>
-          <a:noFill/>
-        </p:spPr>
-        <p:txBody>
-          <a:bodyPr wrap="none">
-            <a:spAutoFit/>
-          </a:bodyPr>
-          <a:lstStyle/>
-          <a:p>
-            <a:r>
-              <a:rPr sz="4400" b="1">
-                <a:solidFill>
-                  <a:srgbClr val="054ADA"/>
-                </a:solidFill>
-              </a:rPr>
-              <a:t>Impact &amp; Technology</a:t>
-            </a:r>
-          </a:p>
-        </p:txBody>
-      </p:sp>
-      <p:sp>
-        <p:nvSpPr>
-          <p:cNvPr id="3" name="TextBox 2"/>
-          <p:cNvSpPr txBox="1"/>
-          <p:nvPr/>
-        </p:nvSpPr>
-        <p:spPr>
-          <a:xfrm>
-            <a:off x="731520" y="1828800"/>
-            <a:ext cx="5029200" cy="4114800"/>
-          </a:xfrm>
-          <a:prstGeom prst="rect">
-            <a:avLst/>
-          </a:prstGeom>
-          <a:noFill/>
-        </p:spPr>
-        <p:txBody>
-          <a:bodyPr wrap="square">
-            <a:spAutoFit/>
-          </a:bodyPr>
-          <a:lstStyle/>
-          <a:p>
-            <a:r>
-              <a:rPr sz="2800" b="1">
-                <a:solidFill>
-                  <a:srgbClr val="1A7A4A"/>
-                </a:solidFill>
-              </a:rPr>
-              <a:t>Impact</a:t>
-            </a:r>
-          </a:p>
-          <a:p>
-            <a:pPr>
-              <a:spcBef>
-                <a:spcPts val="1000"/>
-              </a:spcBef>
-            </a:pPr>
-            <a:r>
-              <a:rPr sz="1800">
-                <a:solidFill>
-                  <a:srgbClr val="333333"/>
-                </a:solidFill>
-              </a:rPr>
-              <a:t>  •  Empowers informal businesses to grow digitally</a:t>
-            </a:r>
-          </a:p>
-          <a:p>
-            <a:pPr>
-              <a:spcBef>
-                <a:spcPts val="1000"/>
-              </a:spcBef>
-            </a:pPr>
-            <a:r>
-              <a:rPr sz="1800">
-                <a:solidFill>
-                  <a:srgbClr val="333333"/>
-                </a:solidFill>
-              </a:rPr>
-              <a:t>  •  Unlocks access to credit</a:t>
-            </a:r>
-          </a:p>
-          <a:p>
-            <a:pPr>
-              <a:spcBef>
-                <a:spcPts val="1000"/>
-              </a:spcBef>
-            </a:pPr>
-            <a:r>
-              <a:rPr sz="1800">
-                <a:solidFill>
-                  <a:srgbClr val="333333"/>
-                </a:solidFill>
-              </a:rPr>
-              <a:t>  •  Boosts visibility in hyperlocal economy</a:t>
-            </a:r>
-          </a:p>
-          <a:p>
-            <a:pPr>
-              <a:spcBef>
-                <a:spcPts val="1000"/>
-              </a:spcBef>
-            </a:pPr>
-            <a:r>
-              <a:rPr sz="1800">
-                <a:solidFill>
-                  <a:srgbClr val="333333"/>
-                </a:solidFill>
-              </a:rPr>
-              <a:t>  •  Serves 5 Crore+ street vendors across India</a:t>
-            </a:r>
-          </a:p>
-        </p:txBody>
-      </p:sp>
-      <p:sp>
-        <p:nvSpPr>
-          <p:cNvPr id="4" name="TextBox 3"/>
-          <p:cNvSpPr txBox="1"/>
-          <p:nvPr/>
-        </p:nvSpPr>
-        <p:spPr>
-          <a:xfrm>
-            <a:off x="6400800" y="1828800"/>
-            <a:ext cx="5029200" cy="4114800"/>
-          </a:xfrm>
-          <a:prstGeom prst="rect">
-            <a:avLst/>
-          </a:prstGeom>
-          <a:noFill/>
-        </p:spPr>
-        <p:txBody>
-          <a:bodyPr wrap="square">
-            <a:spAutoFit/>
-          </a:bodyPr>
-          <a:lstStyle/>
-          <a:p>
-            <a:r>
-              <a:rPr sz="2800" b="1">
-                <a:solidFill>
-                  <a:srgbClr val="054ADA"/>
-                </a:solidFill>
-              </a:rPr>
-              <a:t>Technology</a:t>
-            </a:r>
-          </a:p>
-          <a:p>
-            <a:pPr>
-              <a:spcBef>
-                <a:spcPts val="1000"/>
-              </a:spcBef>
-            </a:pPr>
-            <a:r>
-              <a:rPr sz="1800">
-                <a:solidFill>
-                  <a:srgbClr val="333333"/>
-                </a:solidFill>
-              </a:rPr>
-              <a:t>  •  IBM Cloud Lite services</a:t>
-            </a:r>
-          </a:p>
-          <a:p>
-            <a:pPr>
-              <a:spcBef>
-                <a:spcPts val="1000"/>
-              </a:spcBef>
-            </a:pPr>
-            <a:r>
-              <a:rPr sz="1800">
-                <a:solidFill>
-                  <a:srgbClr val="333333"/>
-                </a:solidFill>
-              </a:rPr>
-              <a:t>  •  IBM Granite / watsonx.ai</a:t>
-            </a:r>
-          </a:p>
-          <a:p>
-            <a:pPr>
-              <a:spcBef>
-                <a:spcPts val="1000"/>
-              </a:spcBef>
-            </a:pPr>
-            <a:r>
-              <a:rPr sz="1800">
-                <a:solidFill>
-                  <a:srgbClr val="333333"/>
-                </a:solidFill>
-              </a:rPr>
-              <a:t>  •  RAG (Retrieval-Augmented Generation)</a:t>
-            </a:r>
-          </a:p>
-          <a:p>
-            <a:pPr>
-              <a:spcBef>
-                <a:spcPts val="1000"/>
-              </a:spcBef>
-            </a:pPr>
-            <a:r>
-              <a:rPr sz="1800">
-                <a:solidFill>
-                  <a:srgbClr val="333333"/>
-                </a:solidFill>
-              </a:rPr>
-              <a:t>  •  Multilingual support (8 Indian languages)</a:t>
-            </a:r>
-          </a:p>
-        </p:txBody>
-      </p:sp>
-    </p:spTree>
-  </p:cSld>
-  <p:clrMapOvr>
-    <a:masterClrMapping/>
-  </p:clrMapOvr>
-</p:sld>
-</file>
-
-<file path=ppt/slides/slide6.xml><?xml version="1.0" encoding="utf-8"?>
-<p:sld xmlns:a="http://schemas.openxmlformats.org/drawingml/2006/main" xmlns:p="http://schemas.openxmlformats.org/presentationml/2006/main" xmlns:r="http://schemas.openxmlformats.org/officeDocument/2006/relationships">
-  <p:cSld>
-    <p:bg>
-      <p:bgPr>
-        <a:solidFill>
-          <a:srgbClr val="0D1B2A"/>
-        </a:solidFill>
-        <a:effectLst/>
-      </p:bgPr>
-    </p:bg>
-    <p:spTree>
-      <p:nvGrpSpPr>
-        <p:cNvPr id="1" name=""/>
-        <p:cNvGrpSpPr/>
-        <p:nvPr/>
-      </p:nvGrpSpPr>
-      <p:grpSpPr/>
-      <p:sp>
-        <p:nvSpPr>
-          <p:cNvPr id="2" name="TextBox 1"/>
-          <p:cNvSpPr txBox="1"/>
-          <p:nvPr/>
-        </p:nvSpPr>
-        <p:spPr>
-          <a:xfrm>
             <a:off x="914400" y="2286000"/>
             <a:ext cx="10058400" cy="1828800"/>
           </a:xfrm>
@@ -4079,40 +3286,6 @@
                 </a:solidFill>
               </a:rPr>
               <a:t>Thank You</a:t>
-            </a:r>
-          </a:p>
-        </p:txBody>
-      </p:sp>
-      <p:sp>
-        <p:nvSpPr>
-          <p:cNvPr id="3" name="TextBox 2"/>
-          <p:cNvSpPr txBox="1"/>
-          <p:nvPr/>
-        </p:nvSpPr>
-        <p:spPr>
-          <a:xfrm>
-            <a:off x="914400" y="4114800"/>
-            <a:ext cx="10058400" cy="1371600"/>
-          </a:xfrm>
-          <a:prstGeom prst="rect">
-            <a:avLst/>
-          </a:prstGeom>
-          <a:noFill/>
-        </p:spPr>
-        <p:txBody>
-          <a:bodyPr wrap="none">
-            <a:spAutoFit/>
-          </a:bodyPr>
-          <a:lstStyle/>
-          <a:p>
-            <a:pPr algn="ctr"/>
-            <a:r>
-              <a:rPr sz="2400">
-                <a:solidFill>
-                  <a:srgbClr val="FFFFFF"/>
-                </a:solidFill>
-              </a:rPr>
-              <a:t>Built with IBM watsonx.ai for India's Street Vendors</a:t>
             </a:r>
           </a:p>
         </p:txBody>

</xml_diff>

<commit_message>
Update Problem Statement 29 PPTX
</commit_message>
<xml_diff>
--- a/Problem_Statement_29.pptx
+++ b/Problem_Statement_29.pptx
@@ -8,6 +8,9 @@
     <p:sldId id="256" r:id="rId7"/>
     <p:sldId id="257" r:id="rId8"/>
     <p:sldId id="258" r:id="rId9"/>
+    <p:sldId id="259" r:id="rId10"/>
+    <p:sldId id="260" r:id="rId11"/>
+    <p:sldId id="261" r:id="rId12"/>
   </p:sldIdLst>
   <p:sldSz cx="12191695" cy="6858000" type="screen4x3"/>
   <p:notesSz cx="6858000" cy="9144000"/>
@@ -3127,7 +3130,7 @@
                   <a:srgbClr val="FF6B00"/>
                 </a:solidFill>
               </a:rPr>
-              <a:t>Problem Statement No.29</a:t>
+              <a:t>Problem Statement No. 29</a:t>
             </a:r>
           </a:p>
         </p:txBody>
@@ -3162,6 +3165,40 @@
                 </a:solidFill>
               </a:rPr>
               <a:t>Street Vendor Digitalization Agent</a:t>
+            </a:r>
+          </a:p>
+        </p:txBody>
+      </p:sp>
+      <p:sp>
+        <p:nvSpPr>
+          <p:cNvPr id="4" name="TextBox 3"/>
+          <p:cNvSpPr txBox="1"/>
+          <p:nvPr/>
+        </p:nvSpPr>
+        <p:spPr>
+          <a:xfrm>
+            <a:off x="914400" y="5029200"/>
+            <a:ext cx="10058400" cy="914400"/>
+          </a:xfrm>
+          <a:prstGeom prst="rect">
+            <a:avLst/>
+          </a:prstGeom>
+          <a:noFill/>
+        </p:spPr>
+        <p:txBody>
+          <a:bodyPr wrap="none">
+            <a:spAutoFit/>
+          </a:bodyPr>
+          <a:lstStyle/>
+          <a:p>
+            <a:pPr algn="ctr"/>
+            <a:r>
+              <a:rPr sz="2400">
+                <a:solidFill>
+                  <a:srgbClr val="1A7A4A"/>
+                </a:solidFill>
+              </a:rPr>
+              <a:t>AICTE-IBM SkillsBuild Internship 2026</a:t>
             </a:r>
           </a:p>
         </p:txBody>
@@ -3200,8 +3237,8 @@
         </p:nvSpPr>
         <p:spPr>
           <a:xfrm>
-            <a:off x="731520" y="365760"/>
-            <a:ext cx="10515600" cy="5943600"/>
+            <a:off x="731520" y="457200"/>
+            <a:ext cx="10058400" cy="914400"/>
           </a:xfrm>
           <a:prstGeom prst="rect">
             <a:avLst/>
@@ -3209,23 +3246,116 @@
           <a:noFill/>
         </p:spPr>
         <p:txBody>
+          <a:bodyPr wrap="none">
+            <a:spAutoFit/>
+          </a:bodyPr>
+          <a:lstStyle/>
+          <a:p>
+            <a:r>
+              <a:rPr sz="4400" b="1">
+                <a:solidFill>
+                  <a:srgbClr val="FF6B00"/>
+                </a:solidFill>
+              </a:rPr>
+              <a:t>The Challenge</a:t>
+            </a:r>
+          </a:p>
+        </p:txBody>
+      </p:sp>
+      <p:sp>
+        <p:nvSpPr>
+          <p:cNvPr id="3" name="TextBox 2"/>
+          <p:cNvSpPr txBox="1"/>
+          <p:nvPr/>
+        </p:nvSpPr>
+        <p:spPr>
+          <a:xfrm>
+            <a:off x="731520" y="1645920"/>
+            <a:ext cx="10515600" cy="4572000"/>
+          </a:xfrm>
+          <a:prstGeom prst="rect">
+            <a:avLst/>
+          </a:prstGeom>
+          <a:noFill/>
+        </p:spPr>
+        <p:txBody>
           <a:bodyPr wrap="square">
             <a:spAutoFit/>
           </a:bodyPr>
           <a:lstStyle/>
           <a:p>
+            <a:pPr>
+              <a:spcAft>
+                <a:spcPts val="1600"/>
+              </a:spcAft>
+            </a:pPr>
             <a:r>
               <a:rPr sz="2200">
                 <a:solidFill>
-                  <a:srgbClr val="222222"/>
+                  <a:srgbClr val="333333"/>
                 </a:solidFill>
               </a:rPr>
-              <a:t>Problem Statement No.29 – Street Vendor Digitalization Agent
-The Challenge – A Street Vendor Digitalization Agent, powered by RAG (Retrieval-Augmented Generation), helps local hawkers and micro-entrepreneurs become digitally visible by generating business profiles, UPI setup guides, local SEO strategies, and customer engagement tips.
-It retrieves real-time policies, MSME schemes, geolocation of business data, digital onboarding steps, and consumer behavior insights from government portals, fintech apps, and commerce platforms.
-Vendors can simply say, "I sell fruit in Pune's Camp area," and the agent will suggest pricing tips, online listing platforms, QR code setup, and promotional materials in their local language.
-This AI-driven assistant empowers informal businesses to grow digitally, unlock access to credit, and boost visibility in the hyperlocal economy.
-Technology – Use of IBM Cloud Lite services / IBM Granite is mandatory.</a:t>
+              <a:t>A Street Vendor Digitalization Agent, powered by RAG (Retrieval-Augmented Generation), helps local hawkers and micro-entrepreneurs become digitally visible by generating:</a:t>
+            </a:r>
+          </a:p>
+          <a:p>
+            <a:pPr>
+              <a:spcBef>
+                <a:spcPts val="800"/>
+              </a:spcBef>
+            </a:pPr>
+            <a:r>
+              <a:rPr sz="2000">
+                <a:solidFill>
+                  <a:srgbClr val="333333"/>
+                </a:solidFill>
+              </a:rPr>
+              <a:t>  •  Business profiles</a:t>
+            </a:r>
+          </a:p>
+          <a:p>
+            <a:pPr>
+              <a:spcBef>
+                <a:spcPts val="800"/>
+              </a:spcBef>
+            </a:pPr>
+            <a:r>
+              <a:rPr sz="2000">
+                <a:solidFill>
+                  <a:srgbClr val="333333"/>
+                </a:solidFill>
+              </a:rPr>
+              <a:t>  •  UPI setup guides</a:t>
+            </a:r>
+          </a:p>
+          <a:p>
+            <a:pPr>
+              <a:spcBef>
+                <a:spcPts val="800"/>
+              </a:spcBef>
+            </a:pPr>
+            <a:r>
+              <a:rPr sz="2000">
+                <a:solidFill>
+                  <a:srgbClr val="333333"/>
+                </a:solidFill>
+              </a:rPr>
+              <a:t>  •  Local SEO strategies</a:t>
+            </a:r>
+          </a:p>
+          <a:p>
+            <a:pPr>
+              <a:spcBef>
+                <a:spcPts val="800"/>
+              </a:spcBef>
+            </a:pPr>
+            <a:r>
+              <a:rPr sz="2000">
+                <a:solidFill>
+                  <a:srgbClr val="333333"/>
+                </a:solidFill>
+              </a:rPr>
+              <a:t>  •  Customer engagement tips</a:t>
             </a:r>
           </a:p>
         </p:txBody>
@@ -3239,6 +3369,238 @@
 </file>
 
 <file path=ppt/slides/slide3.xml><?xml version="1.0" encoding="utf-8"?>
+<p:sld xmlns:a="http://schemas.openxmlformats.org/drawingml/2006/main" xmlns:p="http://schemas.openxmlformats.org/presentationml/2006/main" xmlns:r="http://schemas.openxmlformats.org/officeDocument/2006/relationships">
+  <p:cSld>
+    <p:bg>
+      <p:bgPr>
+        <a:solidFill>
+          <a:srgbClr val="FFFFFF"/>
+        </a:solidFill>
+        <a:effectLst/>
+      </p:bgPr>
+    </p:bg>
+    <p:spTree>
+      <p:nvGrpSpPr>
+        <p:cNvPr id="1" name=""/>
+        <p:cNvGrpSpPr/>
+        <p:nvPr/>
+      </p:nvGrpSpPr>
+      <p:grpSpPr/>
+      <p:sp>
+        <p:nvSpPr>
+          <p:cNvPr id="2" name="TextBox 1"/>
+          <p:cNvSpPr txBox="1"/>
+          <p:nvPr/>
+        </p:nvSpPr>
+        <p:spPr>
+          <a:xfrm>
+            <a:off x="731520" y="457200"/>
+            <a:ext cx="10058400" cy="914400"/>
+          </a:xfrm>
+          <a:prstGeom prst="rect">
+            <a:avLst/>
+          </a:prstGeom>
+          <a:noFill/>
+        </p:spPr>
+        <p:txBody>
+          <a:bodyPr wrap="none">
+            <a:spAutoFit/>
+          </a:bodyPr>
+          <a:lstStyle/>
+          <a:p>
+            <a:r>
+              <a:rPr sz="4400" b="1">
+                <a:solidFill>
+                  <a:srgbClr val="1A7A4A"/>
+                </a:solidFill>
+              </a:rPr>
+              <a:t>What It Does</a:t>
+            </a:r>
+          </a:p>
+        </p:txBody>
+      </p:sp>
+      <p:sp>
+        <p:nvSpPr>
+          <p:cNvPr id="3" name="TextBox 2"/>
+          <p:cNvSpPr txBox="1"/>
+          <p:nvPr/>
+        </p:nvSpPr>
+        <p:spPr>
+          <a:xfrm>
+            <a:off x="731520" y="1645920"/>
+            <a:ext cx="10515600" cy="4572000"/>
+          </a:xfrm>
+          <a:prstGeom prst="rect">
+            <a:avLst/>
+          </a:prstGeom>
+          <a:noFill/>
+        </p:spPr>
+        <p:txBody>
+          <a:bodyPr wrap="square">
+            <a:spAutoFit/>
+          </a:bodyPr>
+          <a:lstStyle/>
+          <a:p>
+            <a:pPr>
+              <a:spcBef>
+                <a:spcPts val="600"/>
+              </a:spcBef>
+            </a:pPr>
+            <a:r>
+              <a:rPr sz="2000" b="1">
+                <a:solidFill>
+                  <a:srgbClr val="333333"/>
+                </a:solidFill>
+              </a:rPr>
+              <a:t>Real-time data retrieval from:</a:t>
+            </a:r>
+          </a:p>
+          <a:p>
+            <a:pPr>
+              <a:spcBef>
+                <a:spcPts val="600"/>
+              </a:spcBef>
+            </a:pPr>
+            <a:r>
+              <a:rPr sz="2000" b="0">
+                <a:solidFill>
+                  <a:srgbClr val="333333"/>
+                </a:solidFill>
+              </a:rPr>
+              <a:t>  •  Government portals</a:t>
+            </a:r>
+          </a:p>
+          <a:p>
+            <a:pPr>
+              <a:spcBef>
+                <a:spcPts val="600"/>
+              </a:spcBef>
+            </a:pPr>
+            <a:r>
+              <a:rPr sz="2000" b="0">
+                <a:solidFill>
+                  <a:srgbClr val="333333"/>
+                </a:solidFill>
+              </a:rPr>
+              <a:t>  •  Fintech apps</a:t>
+            </a:r>
+          </a:p>
+          <a:p>
+            <a:pPr>
+              <a:spcBef>
+                <a:spcPts val="600"/>
+              </a:spcBef>
+            </a:pPr>
+            <a:r>
+              <a:rPr sz="2000" b="0">
+                <a:solidFill>
+                  <a:srgbClr val="333333"/>
+                </a:solidFill>
+              </a:rPr>
+              <a:t>  •  Commerce platforms</a:t>
+            </a:r>
+          </a:p>
+          <a:p>
+            <a:pPr>
+              <a:spcBef>
+                <a:spcPts val="600"/>
+              </a:spcBef>
+            </a:pPr>
+            <a:r>
+              <a:rPr sz="2000" b="0">
+                <a:solidFill>
+                  <a:srgbClr val="333333"/>
+                </a:solidFill>
+              </a:rPr>
+              <a:t/>
+            </a:r>
+          </a:p>
+          <a:p>
+            <a:pPr>
+              <a:spcBef>
+                <a:spcPts val="600"/>
+              </a:spcBef>
+            </a:pPr>
+            <a:r>
+              <a:rPr sz="2000" b="1">
+                <a:solidFill>
+                  <a:srgbClr val="333333"/>
+                </a:solidFill>
+              </a:rPr>
+              <a:t>Retrieves:</a:t>
+            </a:r>
+          </a:p>
+          <a:p>
+            <a:pPr>
+              <a:spcBef>
+                <a:spcPts val="600"/>
+              </a:spcBef>
+            </a:pPr>
+            <a:r>
+              <a:rPr sz="2000" b="0">
+                <a:solidFill>
+                  <a:srgbClr val="333333"/>
+                </a:solidFill>
+              </a:rPr>
+              <a:t>  •  Real-time policies &amp; MSME schemes</a:t>
+            </a:r>
+          </a:p>
+          <a:p>
+            <a:pPr>
+              <a:spcBef>
+                <a:spcPts val="600"/>
+              </a:spcBef>
+            </a:pPr>
+            <a:r>
+              <a:rPr sz="2000" b="0">
+                <a:solidFill>
+                  <a:srgbClr val="333333"/>
+                </a:solidFill>
+              </a:rPr>
+              <a:t>  •  Geolocation of business data</a:t>
+            </a:r>
+          </a:p>
+          <a:p>
+            <a:pPr>
+              <a:spcBef>
+                <a:spcPts val="600"/>
+              </a:spcBef>
+            </a:pPr>
+            <a:r>
+              <a:rPr sz="2000" b="0">
+                <a:solidFill>
+                  <a:srgbClr val="333333"/>
+                </a:solidFill>
+              </a:rPr>
+              <a:t>  •  Digital onboarding steps</a:t>
+            </a:r>
+          </a:p>
+          <a:p>
+            <a:pPr>
+              <a:spcBef>
+                <a:spcPts val="600"/>
+              </a:spcBef>
+            </a:pPr>
+            <a:r>
+              <a:rPr sz="2000" b="0">
+                <a:solidFill>
+                  <a:srgbClr val="333333"/>
+                </a:solidFill>
+              </a:rPr>
+              <a:t>  •  Consumer behavior insights</a:t>
+            </a:r>
+          </a:p>
+        </p:txBody>
+      </p:sp>
+    </p:spTree>
+  </p:cSld>
+  <p:clrMapOvr>
+    <a:masterClrMapping/>
+  </p:clrMapOvr>
+</p:sld>
+</file>
+
+<file path=ppt/slides/slide4.xml><?xml version="1.0" encoding="utf-8"?>
 <p:sld xmlns:a="http://schemas.openxmlformats.org/drawingml/2006/main" xmlns:p="http://schemas.openxmlformats.org/presentationml/2006/main" xmlns:r="http://schemas.openxmlformats.org/officeDocument/2006/relationships">
   <p:cSld>
     <p:bg>
@@ -3264,6 +3626,437 @@
         </p:nvSpPr>
         <p:spPr>
           <a:xfrm>
+            <a:off x="731520" y="457200"/>
+            <a:ext cx="10058400" cy="914400"/>
+          </a:xfrm>
+          <a:prstGeom prst="rect">
+            <a:avLst/>
+          </a:prstGeom>
+          <a:noFill/>
+        </p:spPr>
+        <p:txBody>
+          <a:bodyPr wrap="none">
+            <a:spAutoFit/>
+          </a:bodyPr>
+          <a:lstStyle/>
+          <a:p>
+            <a:r>
+              <a:rPr sz="4400" b="1">
+                <a:solidFill>
+                  <a:srgbClr val="FF6B00"/>
+                </a:solidFill>
+              </a:rPr>
+              <a:t>Example Usage</a:t>
+            </a:r>
+          </a:p>
+        </p:txBody>
+      </p:sp>
+      <p:sp>
+        <p:nvSpPr>
+          <p:cNvPr id="3" name="TextBox 2"/>
+          <p:cNvSpPr txBox="1"/>
+          <p:nvPr/>
+        </p:nvSpPr>
+        <p:spPr>
+          <a:xfrm>
+            <a:off x="731520" y="1828800"/>
+            <a:ext cx="10515600" cy="1371600"/>
+          </a:xfrm>
+          <a:prstGeom prst="rect">
+            <a:avLst/>
+          </a:prstGeom>
+          <a:noFill/>
+        </p:spPr>
+        <p:txBody>
+          <a:bodyPr wrap="square">
+            <a:spAutoFit/>
+          </a:bodyPr>
+          <a:lstStyle/>
+          <a:p>
+            <a:pPr algn="ctr"/>
+            <a:r>
+              <a:rPr sz="3000" i="1">
+                <a:solidFill>
+                  <a:srgbClr val="FFFFFF"/>
+                </a:solidFill>
+              </a:rPr>
+              <a:t>"I sell fruit in Pune's Camp area."</a:t>
+            </a:r>
+          </a:p>
+        </p:txBody>
+      </p:sp>
+      <p:sp>
+        <p:nvSpPr>
+          <p:cNvPr id="4" name="TextBox 3"/>
+          <p:cNvSpPr txBox="1"/>
+          <p:nvPr/>
+        </p:nvSpPr>
+        <p:spPr>
+          <a:xfrm>
+            <a:off x="1371600" y="3657600"/>
+            <a:ext cx="9144000" cy="2743200"/>
+          </a:xfrm>
+          <a:prstGeom prst="rect">
+            <a:avLst/>
+          </a:prstGeom>
+          <a:noFill/>
+        </p:spPr>
+        <p:txBody>
+          <a:bodyPr wrap="square">
+            <a:spAutoFit/>
+          </a:bodyPr>
+          <a:lstStyle/>
+          <a:p>
+            <a:r>
+              <a:rPr sz="2200" b="1">
+                <a:solidFill>
+                  <a:srgbClr val="1A7A4A"/>
+                </a:solidFill>
+              </a:rPr>
+              <a:t>The agent suggests:</a:t>
+            </a:r>
+          </a:p>
+          <a:p>
+            <a:pPr>
+              <a:spcBef>
+                <a:spcPts val="1000"/>
+              </a:spcBef>
+            </a:pPr>
+            <a:r>
+              <a:rPr sz="2000">
+                <a:solidFill>
+                  <a:srgbClr val="FFFFFF"/>
+                </a:solidFill>
+              </a:rPr>
+              <a:t>  ✅  Pricing tips for local market</a:t>
+            </a:r>
+          </a:p>
+          <a:p>
+            <a:pPr>
+              <a:spcBef>
+                <a:spcPts val="1000"/>
+              </a:spcBef>
+            </a:pPr>
+            <a:r>
+              <a:rPr sz="2000">
+                <a:solidFill>
+                  <a:srgbClr val="FFFFFF"/>
+                </a:solidFill>
+              </a:rPr>
+              <a:t>  ✅  Online listing platforms (Google, Swiggy, Zomato)</a:t>
+            </a:r>
+          </a:p>
+          <a:p>
+            <a:pPr>
+              <a:spcBef>
+                <a:spcPts val="1000"/>
+              </a:spcBef>
+            </a:pPr>
+            <a:r>
+              <a:rPr sz="2000">
+                <a:solidFill>
+                  <a:srgbClr val="FFFFFF"/>
+                </a:solidFill>
+              </a:rPr>
+              <a:t>  ✅  QR code setup for UPI payments</a:t>
+            </a:r>
+          </a:p>
+          <a:p>
+            <a:pPr>
+              <a:spcBef>
+                <a:spcPts val="1000"/>
+              </a:spcBef>
+            </a:pPr>
+            <a:r>
+              <a:rPr sz="2000">
+                <a:solidFill>
+                  <a:srgbClr val="FFFFFF"/>
+                </a:solidFill>
+              </a:rPr>
+              <a:t>  ✅  Promotional materials in local language</a:t>
+            </a:r>
+          </a:p>
+        </p:txBody>
+      </p:sp>
+    </p:spTree>
+  </p:cSld>
+  <p:clrMapOvr>
+    <a:masterClrMapping/>
+  </p:clrMapOvr>
+</p:sld>
+</file>
+
+<file path=ppt/slides/slide5.xml><?xml version="1.0" encoding="utf-8"?>
+<p:sld xmlns:a="http://schemas.openxmlformats.org/drawingml/2006/main" xmlns:p="http://schemas.openxmlformats.org/presentationml/2006/main" xmlns:r="http://schemas.openxmlformats.org/officeDocument/2006/relationships">
+  <p:cSld>
+    <p:bg>
+      <p:bgPr>
+        <a:solidFill>
+          <a:srgbClr val="FFFFFF"/>
+        </a:solidFill>
+        <a:effectLst/>
+      </p:bgPr>
+    </p:bg>
+    <p:spTree>
+      <p:nvGrpSpPr>
+        <p:cNvPr id="1" name=""/>
+        <p:cNvGrpSpPr/>
+        <p:nvPr/>
+      </p:nvGrpSpPr>
+      <p:grpSpPr/>
+      <p:sp>
+        <p:nvSpPr>
+          <p:cNvPr id="2" name="TextBox 1"/>
+          <p:cNvSpPr txBox="1"/>
+          <p:nvPr/>
+        </p:nvSpPr>
+        <p:spPr>
+          <a:xfrm>
+            <a:off x="731520" y="457200"/>
+            <a:ext cx="10058400" cy="914400"/>
+          </a:xfrm>
+          <a:prstGeom prst="rect">
+            <a:avLst/>
+          </a:prstGeom>
+          <a:noFill/>
+        </p:spPr>
+        <p:txBody>
+          <a:bodyPr wrap="none">
+            <a:spAutoFit/>
+          </a:bodyPr>
+          <a:lstStyle/>
+          <a:p>
+            <a:r>
+              <a:rPr sz="4400" b="1">
+                <a:solidFill>
+                  <a:srgbClr val="054ADA"/>
+                </a:solidFill>
+              </a:rPr>
+              <a:t>Impact &amp; Technology</a:t>
+            </a:r>
+          </a:p>
+        </p:txBody>
+      </p:sp>
+      <p:sp>
+        <p:nvSpPr>
+          <p:cNvPr id="3" name="TextBox 2"/>
+          <p:cNvSpPr txBox="1"/>
+          <p:nvPr/>
+        </p:nvSpPr>
+        <p:spPr>
+          <a:xfrm>
+            <a:off x="731520" y="1828800"/>
+            <a:ext cx="5029200" cy="4114800"/>
+          </a:xfrm>
+          <a:prstGeom prst="rect">
+            <a:avLst/>
+          </a:prstGeom>
+          <a:noFill/>
+        </p:spPr>
+        <p:txBody>
+          <a:bodyPr wrap="square">
+            <a:spAutoFit/>
+          </a:bodyPr>
+          <a:lstStyle/>
+          <a:p>
+            <a:r>
+              <a:rPr sz="2800" b="1">
+                <a:solidFill>
+                  <a:srgbClr val="1A7A4A"/>
+                </a:solidFill>
+              </a:rPr>
+              <a:t>Impact</a:t>
+            </a:r>
+          </a:p>
+          <a:p>
+            <a:pPr>
+              <a:spcBef>
+                <a:spcPts val="1000"/>
+              </a:spcBef>
+            </a:pPr>
+            <a:r>
+              <a:rPr sz="1800">
+                <a:solidFill>
+                  <a:srgbClr val="333333"/>
+                </a:solidFill>
+              </a:rPr>
+              <a:t>  •  Empowers informal businesses to grow digitally</a:t>
+            </a:r>
+          </a:p>
+          <a:p>
+            <a:pPr>
+              <a:spcBef>
+                <a:spcPts val="1000"/>
+              </a:spcBef>
+            </a:pPr>
+            <a:r>
+              <a:rPr sz="1800">
+                <a:solidFill>
+                  <a:srgbClr val="333333"/>
+                </a:solidFill>
+              </a:rPr>
+              <a:t>  •  Unlocks access to credit</a:t>
+            </a:r>
+          </a:p>
+          <a:p>
+            <a:pPr>
+              <a:spcBef>
+                <a:spcPts val="1000"/>
+              </a:spcBef>
+            </a:pPr>
+            <a:r>
+              <a:rPr sz="1800">
+                <a:solidFill>
+                  <a:srgbClr val="333333"/>
+                </a:solidFill>
+              </a:rPr>
+              <a:t>  •  Boosts visibility in hyperlocal economy</a:t>
+            </a:r>
+          </a:p>
+          <a:p>
+            <a:pPr>
+              <a:spcBef>
+                <a:spcPts val="1000"/>
+              </a:spcBef>
+            </a:pPr>
+            <a:r>
+              <a:rPr sz="1800">
+                <a:solidFill>
+                  <a:srgbClr val="333333"/>
+                </a:solidFill>
+              </a:rPr>
+              <a:t>  •  Serves 5 Crore+ street vendors across India</a:t>
+            </a:r>
+          </a:p>
+        </p:txBody>
+      </p:sp>
+      <p:sp>
+        <p:nvSpPr>
+          <p:cNvPr id="4" name="TextBox 3"/>
+          <p:cNvSpPr txBox="1"/>
+          <p:nvPr/>
+        </p:nvSpPr>
+        <p:spPr>
+          <a:xfrm>
+            <a:off x="6400800" y="1828800"/>
+            <a:ext cx="5029200" cy="4114800"/>
+          </a:xfrm>
+          <a:prstGeom prst="rect">
+            <a:avLst/>
+          </a:prstGeom>
+          <a:noFill/>
+        </p:spPr>
+        <p:txBody>
+          <a:bodyPr wrap="square">
+            <a:spAutoFit/>
+          </a:bodyPr>
+          <a:lstStyle/>
+          <a:p>
+            <a:r>
+              <a:rPr sz="2800" b="1">
+                <a:solidFill>
+                  <a:srgbClr val="054ADA"/>
+                </a:solidFill>
+              </a:rPr>
+              <a:t>Technology</a:t>
+            </a:r>
+          </a:p>
+          <a:p>
+            <a:pPr>
+              <a:spcBef>
+                <a:spcPts val="1000"/>
+              </a:spcBef>
+            </a:pPr>
+            <a:r>
+              <a:rPr sz="1800">
+                <a:solidFill>
+                  <a:srgbClr val="333333"/>
+                </a:solidFill>
+              </a:rPr>
+              <a:t>  •  IBM Cloud Lite services</a:t>
+            </a:r>
+          </a:p>
+          <a:p>
+            <a:pPr>
+              <a:spcBef>
+                <a:spcPts val="1000"/>
+              </a:spcBef>
+            </a:pPr>
+            <a:r>
+              <a:rPr sz="1800">
+                <a:solidFill>
+                  <a:srgbClr val="333333"/>
+                </a:solidFill>
+              </a:rPr>
+              <a:t>  •  IBM Granite / watsonx.ai</a:t>
+            </a:r>
+          </a:p>
+          <a:p>
+            <a:pPr>
+              <a:spcBef>
+                <a:spcPts val="1000"/>
+              </a:spcBef>
+            </a:pPr>
+            <a:r>
+              <a:rPr sz="1800">
+                <a:solidFill>
+                  <a:srgbClr val="333333"/>
+                </a:solidFill>
+              </a:rPr>
+              <a:t>  •  RAG (Retrieval-Augmented Generation)</a:t>
+            </a:r>
+          </a:p>
+          <a:p>
+            <a:pPr>
+              <a:spcBef>
+                <a:spcPts val="1000"/>
+              </a:spcBef>
+            </a:pPr>
+            <a:r>
+              <a:rPr sz="1800">
+                <a:solidFill>
+                  <a:srgbClr val="333333"/>
+                </a:solidFill>
+              </a:rPr>
+              <a:t>  •  Multilingual support (8 Indian languages)</a:t>
+            </a:r>
+          </a:p>
+        </p:txBody>
+      </p:sp>
+    </p:spTree>
+  </p:cSld>
+  <p:clrMapOvr>
+    <a:masterClrMapping/>
+  </p:clrMapOvr>
+</p:sld>
+</file>
+
+<file path=ppt/slides/slide6.xml><?xml version="1.0" encoding="utf-8"?>
+<p:sld xmlns:a="http://schemas.openxmlformats.org/drawingml/2006/main" xmlns:p="http://schemas.openxmlformats.org/presentationml/2006/main" xmlns:r="http://schemas.openxmlformats.org/officeDocument/2006/relationships">
+  <p:cSld>
+    <p:bg>
+      <p:bgPr>
+        <a:solidFill>
+          <a:srgbClr val="0D1B2A"/>
+        </a:solidFill>
+        <a:effectLst/>
+      </p:bgPr>
+    </p:bg>
+    <p:spTree>
+      <p:nvGrpSpPr>
+        <p:cNvPr id="1" name=""/>
+        <p:cNvGrpSpPr/>
+        <p:nvPr/>
+      </p:nvGrpSpPr>
+      <p:grpSpPr/>
+      <p:sp>
+        <p:nvSpPr>
+          <p:cNvPr id="2" name="TextBox 1"/>
+          <p:cNvSpPr txBox="1"/>
+          <p:nvPr/>
+        </p:nvSpPr>
+        <p:spPr>
+          <a:xfrm>
             <a:off x="914400" y="2286000"/>
             <a:ext cx="10058400" cy="1828800"/>
           </a:xfrm>
@@ -3286,6 +4079,40 @@
                 </a:solidFill>
               </a:rPr>
               <a:t>Thank You</a:t>
+            </a:r>
+          </a:p>
+        </p:txBody>
+      </p:sp>
+      <p:sp>
+        <p:nvSpPr>
+          <p:cNvPr id="3" name="TextBox 2"/>
+          <p:cNvSpPr txBox="1"/>
+          <p:nvPr/>
+        </p:nvSpPr>
+        <p:spPr>
+          <a:xfrm>
+            <a:off x="914400" y="4114800"/>
+            <a:ext cx="10058400" cy="1371600"/>
+          </a:xfrm>
+          <a:prstGeom prst="rect">
+            <a:avLst/>
+          </a:prstGeom>
+          <a:noFill/>
+        </p:spPr>
+        <p:txBody>
+          <a:bodyPr wrap="none">
+            <a:spAutoFit/>
+          </a:bodyPr>
+          <a:lstStyle/>
+          <a:p>
+            <a:pPr algn="ctr"/>
+            <a:r>
+              <a:rPr sz="2400">
+                <a:solidFill>
+                  <a:srgbClr val="FFFFFF"/>
+                </a:solidFill>
+              </a:rPr>
+              <a:t>Built with IBM watsonx.ai for India's Street Vendors</a:t>
             </a:r>
           </a:p>
         </p:txBody>

</xml_diff>